<commit_message>
ajustes final apresentação com inclusão de turnover por performance
</commit_message>
<xml_diff>
--- a/apresentacao.pptx
+++ b/apresentacao.pptx
@@ -10,8 +10,9 @@
     <p:sldId id="265" r:id="rId4"/>
     <p:sldId id="261" r:id="rId5"/>
     <p:sldId id="264" r:id="rId6"/>
-    <p:sldId id="262" r:id="rId7"/>
-    <p:sldId id="263" r:id="rId8"/>
+    <p:sldId id="266" r:id="rId7"/>
+    <p:sldId id="262" r:id="rId8"/>
+    <p:sldId id="263" r:id="rId9"/>
   </p:sldIdLst>
   <p:sldSz cx="12192000" cy="6858000"/>
   <p:notesSz cx="6858000" cy="9144000"/>
@@ -121,7 +122,7 @@
 <file path=ppt/revisionInfo.xml><?xml version="1.0" encoding="utf-8"?>
 <p1510:revInfo xmlns:a="http://schemas.openxmlformats.org/drawingml/2006/main" xmlns:r="http://schemas.openxmlformats.org/officeDocument/2006/relationships" xmlns:p1510="http://schemas.microsoft.com/office/powerpoint/2015/10/main">
   <p1510:revLst>
-    <p1510:client id="{356AF510-05BD-4C8F-B311-551965E51313}" v="27" dt="2025-07-06T22:34:30.492"/>
+    <p1510:client id="{356AF510-05BD-4C8F-B311-551965E51313}" v="28" dt="2025-07-07T11:38:49.308"/>
   </p1510:revLst>
 </p1510:revInfo>
 </file>
@@ -131,7 +132,7 @@
   <pc:docChgLst>
     <pc:chgData name="Vinicius Ferreira Andrade" userId="e8718b51-6d56-41fe-b5b4-d516f6028404" providerId="ADAL" clId="{356AF510-05BD-4C8F-B311-551965E51313}"/>
     <pc:docChg chg="undo redo custSel addSld delSld modSld">
-      <pc:chgData name="Vinicius Ferreira Andrade" userId="e8718b51-6d56-41fe-b5b4-d516f6028404" providerId="ADAL" clId="{356AF510-05BD-4C8F-B311-551965E51313}" dt="2025-07-06T22:48:41.583" v="1832" actId="2710"/>
+      <pc:chgData name="Vinicius Ferreira Andrade" userId="e8718b51-6d56-41fe-b5b4-d516f6028404" providerId="ADAL" clId="{356AF510-05BD-4C8F-B311-551965E51313}" dt="2025-07-07T11:39:04.294" v="1933" actId="1076"/>
       <pc:docMkLst>
         <pc:docMk/>
       </pc:docMkLst>
@@ -284,7 +285,7 @@
         </pc:picChg>
       </pc:sldChg>
       <pc:sldChg chg="modSp mod">
-        <pc:chgData name="Vinicius Ferreira Andrade" userId="e8718b51-6d56-41fe-b5b4-d516f6028404" providerId="ADAL" clId="{356AF510-05BD-4C8F-B311-551965E51313}" dt="2025-07-06T22:43:58.192" v="1471" actId="1076"/>
+        <pc:chgData name="Vinicius Ferreira Andrade" userId="e8718b51-6d56-41fe-b5b4-d516f6028404" providerId="ADAL" clId="{356AF510-05BD-4C8F-B311-551965E51313}" dt="2025-07-07T11:38:06.445" v="1918" actId="20577"/>
         <pc:sldMkLst>
           <pc:docMk/>
           <pc:sldMk cId="2443651739" sldId="263"/>
@@ -298,7 +299,7 @@
           </ac:spMkLst>
         </pc:spChg>
         <pc:spChg chg="mod">
-          <ac:chgData name="Vinicius Ferreira Andrade" userId="e8718b51-6d56-41fe-b5b4-d516f6028404" providerId="ADAL" clId="{356AF510-05BD-4C8F-B311-551965E51313}" dt="2025-07-06T22:43:55.593" v="1470" actId="1076"/>
+          <ac:chgData name="Vinicius Ferreira Andrade" userId="e8718b51-6d56-41fe-b5b4-d516f6028404" providerId="ADAL" clId="{356AF510-05BD-4C8F-B311-551965E51313}" dt="2025-07-07T11:38:06.445" v="1918" actId="20577"/>
           <ac:spMkLst>
             <pc:docMk/>
             <pc:sldMk cId="2443651739" sldId="263"/>
@@ -307,7 +308,7 @@
         </pc:spChg>
       </pc:sldChg>
       <pc:sldChg chg="addSp delSp modSp add mod">
-        <pc:chgData name="Vinicius Ferreira Andrade" userId="e8718b51-6d56-41fe-b5b4-d516f6028404" providerId="ADAL" clId="{356AF510-05BD-4C8F-B311-551965E51313}" dt="2025-07-06T22:44:13.928" v="1479" actId="1038"/>
+        <pc:chgData name="Vinicius Ferreira Andrade" userId="e8718b51-6d56-41fe-b5b4-d516f6028404" providerId="ADAL" clId="{356AF510-05BD-4C8F-B311-551965E51313}" dt="2025-07-07T11:39:04.294" v="1933" actId="1076"/>
         <pc:sldMkLst>
           <pc:docMk/>
           <pc:sldMk cId="2661520648" sldId="264"/>
@@ -321,7 +322,7 @@
           </ac:spMkLst>
         </pc:spChg>
         <pc:spChg chg="mod">
-          <ac:chgData name="Vinicius Ferreira Andrade" userId="e8718b51-6d56-41fe-b5b4-d516f6028404" providerId="ADAL" clId="{356AF510-05BD-4C8F-B311-551965E51313}" dt="2025-07-06T22:44:13.928" v="1479" actId="1038"/>
+          <ac:chgData name="Vinicius Ferreira Andrade" userId="e8718b51-6d56-41fe-b5b4-d516f6028404" providerId="ADAL" clId="{356AF510-05BD-4C8F-B311-551965E51313}" dt="2025-07-07T11:38:46.357" v="1927" actId="27636"/>
           <ac:spMkLst>
             <pc:docMk/>
             <pc:sldMk cId="2661520648" sldId="264"/>
@@ -334,6 +335,14 @@
             <pc:docMk/>
             <pc:sldMk cId="2661520648" sldId="264"/>
             <ac:picMk id="5" creationId="{6355ADE1-F0F3-9CA4-DDFE-8E1C72268764}"/>
+          </ac:picMkLst>
+        </pc:picChg>
+        <pc:picChg chg="add del mod">
+          <ac:chgData name="Vinicius Ferreira Andrade" userId="e8718b51-6d56-41fe-b5b4-d516f6028404" providerId="ADAL" clId="{356AF510-05BD-4C8F-B311-551965E51313}" dt="2025-07-07T11:38:13.557" v="1919" actId="478"/>
+          <ac:picMkLst>
+            <pc:docMk/>
+            <pc:sldMk cId="2661520648" sldId="264"/>
+            <ac:picMk id="5" creationId="{92C86CF2-01F9-52BB-6B4C-9620E03AACBC}"/>
           </ac:picMkLst>
         </pc:picChg>
         <pc:picChg chg="add del mod">
@@ -353,7 +362,7 @@
           </ac:picMkLst>
         </pc:picChg>
         <pc:picChg chg="add mod">
-          <ac:chgData name="Vinicius Ferreira Andrade" userId="e8718b51-6d56-41fe-b5b4-d516f6028404" providerId="ADAL" clId="{356AF510-05BD-4C8F-B311-551965E51313}" dt="2025-07-06T22:40:26.859" v="1330" actId="14100"/>
+          <ac:chgData name="Vinicius Ferreira Andrade" userId="e8718b51-6d56-41fe-b5b4-d516f6028404" providerId="ADAL" clId="{356AF510-05BD-4C8F-B311-551965E51313}" dt="2025-07-07T11:39:04.294" v="1933" actId="1076"/>
           <ac:picMkLst>
             <pc:docMk/>
             <pc:sldMk cId="2661520648" sldId="264"/>
@@ -368,8 +377,8 @@
             <ac:picMk id="11" creationId="{CF4957AE-E0A7-B7C7-A552-99731B2E6DD9}"/>
           </ac:picMkLst>
         </pc:picChg>
-        <pc:picChg chg="add mod">
-          <ac:chgData name="Vinicius Ferreira Andrade" userId="e8718b51-6d56-41fe-b5b4-d516f6028404" providerId="ADAL" clId="{356AF510-05BD-4C8F-B311-551965E51313}" dt="2025-07-06T22:40:22.219" v="1329" actId="1037"/>
+        <pc:picChg chg="add del mod">
+          <ac:chgData name="Vinicius Ferreira Andrade" userId="e8718b51-6d56-41fe-b5b4-d516f6028404" providerId="ADAL" clId="{356AF510-05BD-4C8F-B311-551965E51313}" dt="2025-07-07T11:38:19.745" v="1920" actId="478"/>
           <ac:picMkLst>
             <pc:docMk/>
             <pc:sldMk cId="2661520648" sldId="264"/>
@@ -390,6 +399,45 @@
           <pc:docMk/>
           <pc:sldMk cId="4160787487" sldId="265"/>
         </pc:sldMkLst>
+      </pc:sldChg>
+      <pc:sldChg chg="delSp modSp add mod">
+        <pc:chgData name="Vinicius Ferreira Andrade" userId="e8718b51-6d56-41fe-b5b4-d516f6028404" providerId="ADAL" clId="{356AF510-05BD-4C8F-B311-551965E51313}" dt="2025-07-07T11:39:00.936" v="1932" actId="1076"/>
+        <pc:sldMkLst>
+          <pc:docMk/>
+          <pc:sldMk cId="2021962759" sldId="266"/>
+        </pc:sldMkLst>
+        <pc:spChg chg="mod">
+          <ac:chgData name="Vinicius Ferreira Andrade" userId="e8718b51-6d56-41fe-b5b4-d516f6028404" providerId="ADAL" clId="{356AF510-05BD-4C8F-B311-551965E51313}" dt="2025-07-07T11:38:54.688" v="1930" actId="20577"/>
+          <ac:spMkLst>
+            <pc:docMk/>
+            <pc:sldMk cId="2021962759" sldId="266"/>
+            <ac:spMk id="3" creationId="{3E9C65C7-D2E7-EB23-9BF3-5502241DE617}"/>
+          </ac:spMkLst>
+        </pc:spChg>
+        <pc:picChg chg="mod">
+          <ac:chgData name="Vinicius Ferreira Andrade" userId="e8718b51-6d56-41fe-b5b4-d516f6028404" providerId="ADAL" clId="{356AF510-05BD-4C8F-B311-551965E51313}" dt="2025-07-07T11:39:00.936" v="1932" actId="1076"/>
+          <ac:picMkLst>
+            <pc:docMk/>
+            <pc:sldMk cId="2021962759" sldId="266"/>
+            <ac:picMk id="5" creationId="{F6B5EB92-042C-54B3-3BCA-354FD0B07E18}"/>
+          </ac:picMkLst>
+        </pc:picChg>
+        <pc:picChg chg="del">
+          <ac:chgData name="Vinicius Ferreira Andrade" userId="e8718b51-6d56-41fe-b5b4-d516f6028404" providerId="ADAL" clId="{356AF510-05BD-4C8F-B311-551965E51313}" dt="2025-07-07T11:37:33.147" v="1885" actId="478"/>
+          <ac:picMkLst>
+            <pc:docMk/>
+            <pc:sldMk cId="2021962759" sldId="266"/>
+            <ac:picMk id="9" creationId="{0AC3EF9B-5D5C-69A5-240A-5D103E4D1BFA}"/>
+          </ac:picMkLst>
+        </pc:picChg>
+        <pc:picChg chg="mod">
+          <ac:chgData name="Vinicius Ferreira Andrade" userId="e8718b51-6d56-41fe-b5b4-d516f6028404" providerId="ADAL" clId="{356AF510-05BD-4C8F-B311-551965E51313}" dt="2025-07-07T11:38:58.197" v="1931" actId="1076"/>
+          <ac:picMkLst>
+            <pc:docMk/>
+            <pc:sldMk cId="2021962759" sldId="266"/>
+            <ac:picMk id="13" creationId="{57D923EE-ADFC-F27B-7F81-E2B3D5FB853F}"/>
+          </ac:picMkLst>
+        </pc:picChg>
       </pc:sldChg>
     </pc:docChg>
   </pc:docChgLst>
@@ -583,7 +631,7 @@
           <a:p>
             <a:fld id="{6D09A51D-73E5-4C12-BF7E-070C226701FA}" type="datetimeFigureOut">
               <a:rPr lang="pt-BR" smtClean="0"/>
-              <a:t>06/07/2025</a:t>
+              <a:t>07/07/2025</a:t>
             </a:fld>
             <a:endParaRPr lang="pt-BR"/>
           </a:p>
@@ -781,7 +829,7 @@
           <a:p>
             <a:fld id="{6D09A51D-73E5-4C12-BF7E-070C226701FA}" type="datetimeFigureOut">
               <a:rPr lang="pt-BR" smtClean="0"/>
-              <a:t>06/07/2025</a:t>
+              <a:t>07/07/2025</a:t>
             </a:fld>
             <a:endParaRPr lang="pt-BR"/>
           </a:p>
@@ -989,7 +1037,7 @@
           <a:p>
             <a:fld id="{6D09A51D-73E5-4C12-BF7E-070C226701FA}" type="datetimeFigureOut">
               <a:rPr lang="pt-BR" smtClean="0"/>
-              <a:t>06/07/2025</a:t>
+              <a:t>07/07/2025</a:t>
             </a:fld>
             <a:endParaRPr lang="pt-BR"/>
           </a:p>
@@ -1187,7 +1235,7 @@
           <a:p>
             <a:fld id="{6D09A51D-73E5-4C12-BF7E-070C226701FA}" type="datetimeFigureOut">
               <a:rPr lang="pt-BR" smtClean="0"/>
-              <a:t>06/07/2025</a:t>
+              <a:t>07/07/2025</a:t>
             </a:fld>
             <a:endParaRPr lang="pt-BR"/>
           </a:p>
@@ -1462,7 +1510,7 @@
           <a:p>
             <a:fld id="{6D09A51D-73E5-4C12-BF7E-070C226701FA}" type="datetimeFigureOut">
               <a:rPr lang="pt-BR" smtClean="0"/>
-              <a:t>06/07/2025</a:t>
+              <a:t>07/07/2025</a:t>
             </a:fld>
             <a:endParaRPr lang="pt-BR"/>
           </a:p>
@@ -1727,7 +1775,7 @@
           <a:p>
             <a:fld id="{6D09A51D-73E5-4C12-BF7E-070C226701FA}" type="datetimeFigureOut">
               <a:rPr lang="pt-BR" smtClean="0"/>
-              <a:t>06/07/2025</a:t>
+              <a:t>07/07/2025</a:t>
             </a:fld>
             <a:endParaRPr lang="pt-BR"/>
           </a:p>
@@ -2139,7 +2187,7 @@
           <a:p>
             <a:fld id="{6D09A51D-73E5-4C12-BF7E-070C226701FA}" type="datetimeFigureOut">
               <a:rPr lang="pt-BR" smtClean="0"/>
-              <a:t>06/07/2025</a:t>
+              <a:t>07/07/2025</a:t>
             </a:fld>
             <a:endParaRPr lang="pt-BR"/>
           </a:p>
@@ -2280,7 +2328,7 @@
           <a:p>
             <a:fld id="{6D09A51D-73E5-4C12-BF7E-070C226701FA}" type="datetimeFigureOut">
               <a:rPr lang="pt-BR" smtClean="0"/>
-              <a:t>06/07/2025</a:t>
+              <a:t>07/07/2025</a:t>
             </a:fld>
             <a:endParaRPr lang="pt-BR"/>
           </a:p>
@@ -2393,7 +2441,7 @@
           <a:p>
             <a:fld id="{6D09A51D-73E5-4C12-BF7E-070C226701FA}" type="datetimeFigureOut">
               <a:rPr lang="pt-BR" smtClean="0"/>
-              <a:t>06/07/2025</a:t>
+              <a:t>07/07/2025</a:t>
             </a:fld>
             <a:endParaRPr lang="pt-BR"/>
           </a:p>
@@ -2704,7 +2752,7 @@
           <a:p>
             <a:fld id="{6D09A51D-73E5-4C12-BF7E-070C226701FA}" type="datetimeFigureOut">
               <a:rPr lang="pt-BR" smtClean="0"/>
-              <a:t>06/07/2025</a:t>
+              <a:t>07/07/2025</a:t>
             </a:fld>
             <a:endParaRPr lang="pt-BR"/>
           </a:p>
@@ -2992,7 +3040,7 @@
           <a:p>
             <a:fld id="{6D09A51D-73E5-4C12-BF7E-070C226701FA}" type="datetimeFigureOut">
               <a:rPr lang="pt-BR" smtClean="0"/>
-              <a:t>06/07/2025</a:t>
+              <a:t>07/07/2025</a:t>
             </a:fld>
             <a:endParaRPr lang="pt-BR"/>
           </a:p>
@@ -3233,7 +3281,7 @@
           <a:p>
             <a:fld id="{6D09A51D-73E5-4C12-BF7E-070C226701FA}" type="datetimeFigureOut">
               <a:rPr lang="pt-BR" smtClean="0"/>
-              <a:t>06/07/2025</a:t>
+              <a:t>07/07/2025</a:t>
             </a:fld>
             <a:endParaRPr lang="pt-BR"/>
           </a:p>
@@ -4407,22 +4455,6 @@
             </a:r>
           </a:p>
           <a:p>
-            <a:r>
-              <a:rPr lang="pt-BR" dirty="0">
-                <a:latin typeface="Garamond" panose="02020404030301010803" pitchFamily="18" charset="0"/>
-              </a:rPr>
-              <a:t>Média banco de horas e hora extra sem variação significativa.</a:t>
-            </a:r>
-          </a:p>
-          <a:p>
-            <a:r>
-              <a:rPr lang="pt-BR" dirty="0">
-                <a:latin typeface="Garamond" panose="02020404030301010803" pitchFamily="18" charset="0"/>
-              </a:rPr>
-              <a:t>Média de salário sem variação significativa.</a:t>
-            </a:r>
-          </a:p>
-          <a:p>
             <a:endParaRPr lang="pt-BR" dirty="0"/>
           </a:p>
         </p:txBody>
@@ -4449,38 +4481,8 @@
         </p:blipFill>
         <p:spPr>
           <a:xfrm>
-            <a:off x="31899" y="4036209"/>
-            <a:ext cx="6602817" cy="2379153"/>
-          </a:xfrm>
-          <a:prstGeom prst="rect">
-            <a:avLst/>
-          </a:prstGeom>
-        </p:spPr>
-      </p:pic>
-      <p:pic>
-        <p:nvPicPr>
-          <p:cNvPr id="13" name="Imagem 12">
-            <a:extLst>
-              <a:ext uri="{FF2B5EF4-FFF2-40B4-BE49-F238E27FC236}">
-                <a16:creationId xmlns:a16="http://schemas.microsoft.com/office/drawing/2014/main" id="{F719EC82-11A3-3798-E16E-0FAE4A5A2A92}"/>
-              </a:ext>
-            </a:extLst>
-          </p:cNvPr>
-          <p:cNvPicPr>
-            <a:picLocks noChangeAspect="1"/>
-          </p:cNvPicPr>
-          <p:nvPr/>
-        </p:nvPicPr>
-        <p:blipFill>
-          <a:blip r:embed="rId3"/>
-          <a:stretch>
-            <a:fillRect/>
-          </a:stretch>
-        </p:blipFill>
-        <p:spPr>
-          <a:xfrm>
-            <a:off x="6482306" y="4089374"/>
-            <a:ext cx="5677795" cy="2154341"/>
+            <a:off x="2062559" y="3319732"/>
+            <a:ext cx="7566329" cy="2726329"/>
           </a:xfrm>
           <a:prstGeom prst="rect">
             <a:avLst/>
@@ -4516,6 +4518,193 @@
         <p:cNvPr id="1" name="">
           <a:extLst>
             <a:ext uri="{FF2B5EF4-FFF2-40B4-BE49-F238E27FC236}">
+              <a16:creationId xmlns:a16="http://schemas.microsoft.com/office/drawing/2014/main" id="{445B0454-0402-FFBF-2F3C-AACCD0028390}"/>
+            </a:ext>
+          </a:extLst>
+        </p:cNvPr>
+        <p:cNvGrpSpPr/>
+        <p:nvPr/>
+      </p:nvGrpSpPr>
+      <p:grpSpPr>
+        <a:xfrm>
+          <a:off x="0" y="0"/>
+          <a:ext cx="0" cy="0"/>
+          <a:chOff x="0" y="0"/>
+          <a:chExt cx="0" cy="0"/>
+        </a:xfrm>
+      </p:grpSpPr>
+      <p:sp>
+        <p:nvSpPr>
+          <p:cNvPr id="2" name="Título 1">
+            <a:extLst>
+              <a:ext uri="{FF2B5EF4-FFF2-40B4-BE49-F238E27FC236}">
+                <a16:creationId xmlns:a16="http://schemas.microsoft.com/office/drawing/2014/main" id="{2B5C980C-B0B7-0FA7-3EE2-9C412DE01B87}"/>
+              </a:ext>
+            </a:extLst>
+          </p:cNvPr>
+          <p:cNvSpPr>
+            <a:spLocks noGrp="1"/>
+          </p:cNvSpPr>
+          <p:nvPr>
+            <p:ph type="title"/>
+          </p:nvPr>
+        </p:nvSpPr>
+        <p:spPr>
+          <a:xfrm>
+            <a:off x="587924" y="571282"/>
+            <a:ext cx="10515600" cy="869497"/>
+          </a:xfrm>
+        </p:spPr>
+        <p:txBody>
+          <a:bodyPr/>
+          <a:lstStyle/>
+          <a:p>
+            <a:r>
+              <a:rPr lang="pt-BR" dirty="0">
+                <a:latin typeface="Garamond" panose="02020404030301010803" pitchFamily="18" charset="0"/>
+              </a:rPr>
+              <a:t>Turnover: Análise possíveis causas</a:t>
+            </a:r>
+          </a:p>
+        </p:txBody>
+      </p:sp>
+      <p:sp>
+        <p:nvSpPr>
+          <p:cNvPr id="3" name="Espaço Reservado para Conteúdo 2">
+            <a:extLst>
+              <a:ext uri="{FF2B5EF4-FFF2-40B4-BE49-F238E27FC236}">
+                <a16:creationId xmlns:a16="http://schemas.microsoft.com/office/drawing/2014/main" id="{3E9C65C7-D2E7-EB23-9BF3-5502241DE617}"/>
+              </a:ext>
+            </a:extLst>
+          </p:cNvPr>
+          <p:cNvSpPr>
+            <a:spLocks noGrp="1"/>
+          </p:cNvSpPr>
+          <p:nvPr>
+            <p:ph idx="1"/>
+          </p:nvPr>
+        </p:nvSpPr>
+        <p:spPr>
+          <a:xfrm>
+            <a:off x="587924" y="1687906"/>
+            <a:ext cx="11689140" cy="2154341"/>
+          </a:xfrm>
+        </p:spPr>
+        <p:txBody>
+          <a:bodyPr>
+            <a:normAutofit/>
+          </a:bodyPr>
+          <a:lstStyle/>
+          <a:p>
+            <a:r>
+              <a:rPr lang="pt-BR" dirty="0">
+                <a:latin typeface="Garamond" panose="02020404030301010803" pitchFamily="18" charset="0"/>
+              </a:rPr>
+              <a:t>Média de salário sem variação significativa.</a:t>
+            </a:r>
+          </a:p>
+          <a:p>
+            <a:r>
+              <a:rPr lang="pt-BR" dirty="0">
+                <a:latin typeface="Garamond" panose="02020404030301010803" pitchFamily="18" charset="0"/>
+              </a:rPr>
+              <a:t>Média de performance sem variação significativa</a:t>
+            </a:r>
+          </a:p>
+          <a:p>
+            <a:endParaRPr lang="pt-BR" dirty="0"/>
+          </a:p>
+        </p:txBody>
+      </p:sp>
+      <p:pic>
+        <p:nvPicPr>
+          <p:cNvPr id="13" name="Imagem 12">
+            <a:extLst>
+              <a:ext uri="{FF2B5EF4-FFF2-40B4-BE49-F238E27FC236}">
+                <a16:creationId xmlns:a16="http://schemas.microsoft.com/office/drawing/2014/main" id="{57D923EE-ADFC-F27B-7F81-E2B3D5FB853F}"/>
+              </a:ext>
+            </a:extLst>
+          </p:cNvPr>
+          <p:cNvPicPr>
+            <a:picLocks noChangeAspect="1"/>
+          </p:cNvPicPr>
+          <p:nvPr/>
+        </p:nvPicPr>
+        <p:blipFill>
+          <a:blip r:embed="rId2"/>
+          <a:stretch>
+            <a:fillRect/>
+          </a:stretch>
+        </p:blipFill>
+        <p:spPr>
+          <a:xfrm>
+            <a:off x="248487" y="3429000"/>
+            <a:ext cx="5677795" cy="2154341"/>
+          </a:xfrm>
+          <a:prstGeom prst="rect">
+            <a:avLst/>
+          </a:prstGeom>
+        </p:spPr>
+      </p:pic>
+      <p:pic>
+        <p:nvPicPr>
+          <p:cNvPr id="5" name="Imagem 4">
+            <a:extLst>
+              <a:ext uri="{FF2B5EF4-FFF2-40B4-BE49-F238E27FC236}">
+                <a16:creationId xmlns:a16="http://schemas.microsoft.com/office/drawing/2014/main" id="{F6B5EB92-042C-54B3-3BCA-354FD0B07E18}"/>
+              </a:ext>
+            </a:extLst>
+          </p:cNvPr>
+          <p:cNvPicPr>
+            <a:picLocks noChangeAspect="1"/>
+          </p:cNvPicPr>
+          <p:nvPr/>
+        </p:nvPicPr>
+        <p:blipFill>
+          <a:blip r:embed="rId3"/>
+          <a:stretch>
+            <a:fillRect/>
+          </a:stretch>
+        </p:blipFill>
+        <p:spPr>
+          <a:xfrm>
+            <a:off x="6093432" y="3429000"/>
+            <a:ext cx="5850081" cy="2152489"/>
+          </a:xfrm>
+          <a:prstGeom prst="rect">
+            <a:avLst/>
+          </a:prstGeom>
+        </p:spPr>
+      </p:pic>
+    </p:spTree>
+    <p:extLst>
+      <p:ext uri="{BB962C8B-B14F-4D97-AF65-F5344CB8AC3E}">
+        <p14:creationId xmlns:p14="http://schemas.microsoft.com/office/powerpoint/2010/main" val="2021962759"/>
+      </p:ext>
+    </p:extLst>
+  </p:cSld>
+  <p:clrMapOvr>
+    <a:masterClrMapping/>
+  </p:clrMapOvr>
+</p:sld>
+</file>
+
+<file path=ppt/slides/slide7.xml><?xml version="1.0" encoding="utf-8"?>
+<p:sld xmlns:a="http://schemas.openxmlformats.org/drawingml/2006/main" xmlns:r="http://schemas.openxmlformats.org/officeDocument/2006/relationships" xmlns:p="http://schemas.openxmlformats.org/presentationml/2006/main">
+  <p:cSld>
+    <p:bg>
+      <p:bgPr>
+        <a:solidFill>
+          <a:srgbClr val="E8EDF5"/>
+        </a:solidFill>
+        <a:effectLst/>
+      </p:bgPr>
+    </p:bg>
+    <p:spTree>
+      <p:nvGrpSpPr>
+        <p:cNvPr id="1" name="">
+          <a:extLst>
+            <a:ext uri="{FF2B5EF4-FFF2-40B4-BE49-F238E27FC236}">
               <a16:creationId xmlns:a16="http://schemas.microsoft.com/office/drawing/2014/main" id="{E338E989-B30B-EC5C-6D47-3FC2EC574929}"/>
             </a:ext>
           </a:extLst>
@@ -4721,7 +4910,7 @@
 </p:sld>
 </file>
 
-<file path=ppt/slides/slide7.xml><?xml version="1.0" encoding="utf-8"?>
+<file path=ppt/slides/slide8.xml><?xml version="1.0" encoding="utf-8"?>
 <p:sld xmlns:a="http://schemas.openxmlformats.org/drawingml/2006/main" xmlns:r="http://schemas.openxmlformats.org/officeDocument/2006/relationships" xmlns:p="http://schemas.openxmlformats.org/presentationml/2006/main">
   <p:cSld>
     <p:bg>
@@ -4811,7 +5000,7 @@
         </p:spPr>
         <p:txBody>
           <a:bodyPr>
-            <a:normAutofit/>
+            <a:normAutofit fontScale="92500" lnSpcReduction="10000"/>
           </a:bodyPr>
           <a:lstStyle/>
           <a:p>
@@ -4838,6 +5027,19 @@
                 <a:latin typeface="Garamond" panose="02020404030301010803" pitchFamily="18" charset="0"/>
               </a:rPr>
               <a:t>Definir metas para Turnover e Diversidade.</a:t>
+            </a:r>
+          </a:p>
+          <a:p>
+            <a:pPr>
+              <a:lnSpc>
+                <a:spcPct val="150000"/>
+              </a:lnSpc>
+            </a:pPr>
+            <a:r>
+              <a:rPr lang="pt-BR" dirty="0">
+                <a:latin typeface="Garamond" panose="02020404030301010803" pitchFamily="18" charset="0"/>
+              </a:rPr>
+              <a:t>Plano de ação com áreas</a:t>
             </a:r>
           </a:p>
           <a:p>

</xml_diff>